<commit_message>
Add legal basis to owner opinion deck
Signed-off-by: JW Design <jwcesign@cloudpilot.ai>
</commit_message>
<xml_diff>
--- a/files/project-entrance-owner-opinion.pptx
+++ b/files/project-entrance-owner-opinion.pptx
@@ -2,18 +2,18 @@
 <file path=ppt/presentation.xml><?xml version="1.0" encoding="utf-8"?>
 <p:presentation xmlns:p="http://schemas.openxmlformats.org/presentationml/2006/main">
   <p:sldMasterIdLst>
-    <p:sldMasterId xmlns:r="http://schemas.openxmlformats.org/officeDocument/2006/relationships" id="2147483648" r:id="R623babc304d04212"/>
+    <p:sldMasterId xmlns:r="http://schemas.openxmlformats.org/officeDocument/2006/relationships" id="2147483648" r:id="Rf7818533dafa4619"/>
   </p:sldMasterIdLst>
   <p:notesMasterIdLst>
-    <p:notesMasterId xmlns:r="http://schemas.openxmlformats.org/officeDocument/2006/relationships" r:id="R31e5b199c0cc4cb2"/>
+    <p:notesMasterId xmlns:r="http://schemas.openxmlformats.org/officeDocument/2006/relationships" r:id="Rcf0994594ec849e9"/>
   </p:notesMasterIdLst>
   <p:sldIdLst>
-    <p:sldId xmlns:r="http://schemas.openxmlformats.org/officeDocument/2006/relationships" id="256" r:id="R9af7293364bb492a"/>
-    <p:sldId xmlns:r="http://schemas.openxmlformats.org/officeDocument/2006/relationships" id="257" r:id="Rf5a691a7ead04efa"/>
-    <p:sldId xmlns:r="http://schemas.openxmlformats.org/officeDocument/2006/relationships" id="258" r:id="Racd7bc116bea468f"/>
-    <p:sldId xmlns:r="http://schemas.openxmlformats.org/officeDocument/2006/relationships" id="259" r:id="Rd89ebc87e58e4a74"/>
-    <p:sldId xmlns:r="http://schemas.openxmlformats.org/officeDocument/2006/relationships" id="260" r:id="R64ba11e59d3b4373"/>
-    <p:sldId xmlns:r="http://schemas.openxmlformats.org/officeDocument/2006/relationships" id="261" r:id="Rae12cf6ccce84fc9"/>
+    <p:sldId xmlns:r="http://schemas.openxmlformats.org/officeDocument/2006/relationships" id="256" r:id="Rfaeec79eef9c4b33"/>
+    <p:sldId xmlns:r="http://schemas.openxmlformats.org/officeDocument/2006/relationships" id="257" r:id="Rd8f552b0b9c34fb1"/>
+    <p:sldId xmlns:r="http://schemas.openxmlformats.org/officeDocument/2006/relationships" id="258" r:id="Rb04b5df9a0844e1c"/>
+    <p:sldId xmlns:r="http://schemas.openxmlformats.org/officeDocument/2006/relationships" id="259" r:id="Rf0935cc08add4acf"/>
+    <p:sldId xmlns:r="http://schemas.openxmlformats.org/officeDocument/2006/relationships" id="260" r:id="Rd3220641fa0141dc"/>
+    <p:sldId xmlns:r="http://schemas.openxmlformats.org/officeDocument/2006/relationships" id="261" r:id="R14d2e0875c0a434f"/>
   </p:sldIdLst>
   <p:sldSz cx="12192000" cy="6858000"/>
   <p:notesSz cx="6858000" cy="9144000"/>
@@ -447,7 +447,7 @@
           <a:lstStyle xmlns:a="http://schemas.openxmlformats.org/drawingml/2006/main"/>
           <a:p xmlns:a="http://schemas.openxmlformats.org/drawingml/2006/main">
             <a:r>
-              <a:t>本材料用于业主就入口整改事项向开发商提出正式意见。目前仅确认后续需要整改，具体范围、方式和最终效果尚未明确。请开发商就整改依据、书面方案、品质补救及补偿安排作出回复。图片由业主提供。</a:t>
+              <a:t>本材料用于业主就入口整改事项向开发商提出正式意见。目前仅确认后续需要整改，具体范围、方式和最终效果尚未明确。相关争议可能涉及订约诚信、具体销售说明和允诺、规划设计变更通知等法律规则；具体适用及责任范围，以合同、宣传材料、审批文件、实际影响及主管部门意见为准。请开发商就整改依据、书面方案、品质补救及补偿安排作出回复。图片由业主提供。</a:t>
             </a:r>
           </a:p>
         </p:txBody>
@@ -657,7 +657,7 @@
           <a:lstStyle xmlns:a="http://schemas.openxmlformats.org/drawingml/2006/main"/>
           <a:p xmlns:a="http://schemas.openxmlformats.org/drawingml/2006/main">
             <a:r>
-              <a:t>本页列明业主立场：销售展示与后续整改之间存在需要解释的矛盾，且具体整改方案尚未明确。要求开发商书面说明相关限制的知悉时间、销售阶段告知情况，并提交整改、品质补救及补偿方案。最终责任认定以合同、宣传材料、审批文件及主管部门意见为准。</a:t>
+              <a:t>本页列明初步法律依据：一、《中华人民共和国民法典》第五百条规定订约阶段故意隐瞒与订立合同有关的重要事实、提供虚假情况或者有其他违背诚信原则的行为，造成对方损失的，应承担赔偿责任。二、《最高人民法院关于审理商品房买卖合同纠纷案件适用法律若干问题的解释》第三条规定，对开发规划范围内房屋及相关设施作出的具体说明和允诺，如对合同订立及价格有重大影响，可以构成合同内容。三、《商品房销售管理办法》第二十四条规定，特定规划、设计变更影响商品房质量或者使用功能时，开发企业负有书面通知义务。上述规则是否适用于本项目及责任范围，仍应结合合同、宣传材料、审批文件、实际影响及主管部门意见认定。</a:t>
             </a:r>
           </a:p>
         </p:txBody>
@@ -2665,12 +2665,12 @@
   </p:cSld>
   <p:clrMap bg1="lt1" tx1="dk1" bg2="lt2" tx2="dk2" accent1="accent1" accent2="accent2" accent3="accent3" accent4="accent4" accent5="accent5" accent6="accent6" hlink="hlink" folHlink="folHlink"/>
   <p:sldLayoutIdLst>
-    <p:sldLayoutId xmlns:r="http://schemas.openxmlformats.org/officeDocument/2006/relationships" id="2147483649" r:id="R7d1dc6330e424675"/>
-    <p:sldLayoutId xmlns:r="http://schemas.openxmlformats.org/officeDocument/2006/relationships" id="2147483650" r:id="R1168af7da8ee4b4f"/>
-    <p:sldLayoutId xmlns:r="http://schemas.openxmlformats.org/officeDocument/2006/relationships" id="2147483651" r:id="Ra3a4853d1b5d4033"/>
-    <p:sldLayoutId xmlns:r="http://schemas.openxmlformats.org/officeDocument/2006/relationships" id="2147483652" r:id="R1c11126175a04547"/>
-    <p:sldLayoutId xmlns:r="http://schemas.openxmlformats.org/officeDocument/2006/relationships" id="2147483653" r:id="R9d0125a35aa645f5"/>
-    <p:sldLayoutId xmlns:r="http://schemas.openxmlformats.org/officeDocument/2006/relationships" id="2147483654" r:id="Rabefbd9bb5e440b8"/>
+    <p:sldLayoutId xmlns:r="http://schemas.openxmlformats.org/officeDocument/2006/relationships" id="2147483649" r:id="R28fd7e038da34cb4"/>
+    <p:sldLayoutId xmlns:r="http://schemas.openxmlformats.org/officeDocument/2006/relationships" id="2147483650" r:id="Rb6ebf7ac54e44319"/>
+    <p:sldLayoutId xmlns:r="http://schemas.openxmlformats.org/officeDocument/2006/relationships" id="2147483651" r:id="Racabd0ebb99b460b"/>
+    <p:sldLayoutId xmlns:r="http://schemas.openxmlformats.org/officeDocument/2006/relationships" id="2147483652" r:id="R5a671ec4df494fe2"/>
+    <p:sldLayoutId xmlns:r="http://schemas.openxmlformats.org/officeDocument/2006/relationships" id="2147483653" r:id="R55203828fe1f4938"/>
+    <p:sldLayoutId xmlns:r="http://schemas.openxmlformats.org/officeDocument/2006/relationships" id="2147483654" r:id="Rcb6542d61359400f"/>
   </p:sldLayoutIdLst>
   <p:txStyles>
     <p:titleStyle>
@@ -3225,7 +3225,7 @@
           <p:nvPr/>
         </p:nvPicPr>
         <p:blipFill>
-          <a:blip xmlns:r="http://schemas.openxmlformats.org/officeDocument/2006/relationships" xmlns:a="http://schemas.openxmlformats.org/drawingml/2006/main" r:embed="Rfa4d357ea01a49f1"/>
+          <a:blip xmlns:r="http://schemas.openxmlformats.org/officeDocument/2006/relationships" xmlns:a="http://schemas.openxmlformats.org/drawingml/2006/main" r:embed="Rd4445781180d4e29"/>
           <a:srcRect xmlns:a="http://schemas.openxmlformats.org/drawingml/2006/main" l="0" t="0" r="0" b="0"/>
           <a:stretch xmlns:a="http://schemas.openxmlformats.org/drawingml/2006/main">
             <a:fillRect l="0" t="0" r="0" b="0"/>
@@ -3376,7 +3376,7 @@
                 <a:ea typeface="Alibaba PuHuiTi 3.0"/>
                 <a:cs typeface="Alibaba PuHuiTi 3.0"/>
               </a:rPr>
-              <a:t>业主沟通意见</a:t>
+              <a:t>法律依据 · 业主沟通意见</a:t>
             </a:r>
           </a:p>
         </p:txBody>
@@ -3434,7 +3434,7 @@
                 <a:ea typeface="Alibaba PuHuiTi 3.0"/>
                 <a:cs typeface="Alibaba PuHuiTi 3.0"/>
               </a:rPr>
-              <a:t>销售展示与后续整改存在矛盾，要求明确方案并协商补偿</a:t>
+              <a:t>销售展示与后续整改的矛盾，有明确法律规则可循</a:t>
             </a:r>
           </a:p>
         </p:txBody>
@@ -4028,7 +4028,7 @@
           <p:nvPr/>
         </p:nvPicPr>
         <p:blipFill>
-          <a:blip xmlns:r="http://schemas.openxmlformats.org/officeDocument/2006/relationships" xmlns:a="http://schemas.openxmlformats.org/drawingml/2006/main" r:embed="R493cc9f4187c4470"/>
+          <a:blip xmlns:r="http://schemas.openxmlformats.org/officeDocument/2006/relationships" xmlns:a="http://schemas.openxmlformats.org/drawingml/2006/main" r:embed="R69084ef51d2d4268"/>
           <a:stretch xmlns:a="http://schemas.openxmlformats.org/drawingml/2006/main"/>
         </p:blipFill>
         <p:spPr>
@@ -4413,7 +4413,7 @@
                 <a:ea typeface="Alibaba PuHuiTi 3.0"/>
                 <a:cs typeface="Alibaba PuHuiTi 3.0"/>
               </a:rPr>
-              <a:t>销售展示与后续整改存在矛盾</a:t>
+              <a:t>销售展示与后续整改的矛盾，有法可依</a:t>
             </a:r>
           </a:p>
         </p:txBody>
@@ -4703,7 +4703,7 @@
                 <a:ea typeface="Alibaba PuHuiTi 3.0"/>
                 <a:cs typeface="Alibaba PuHuiTi 3.0"/>
               </a:rPr>
-              <a:t>销售阶段是否已知相关限制</a:t>
+              <a:t>已知未告知，可能涉及缔约过失责任</a:t>
             </a:r>
           </a:p>
         </p:txBody>
@@ -4761,7 +4761,7 @@
                 <a:ea typeface="Alibaba PuHuiTi 3.0"/>
                 <a:cs typeface="Alibaba PuHuiTi 3.0"/>
               </a:rPr>
-              <a:t>若开发商已知或应知方案无法落地，却未作出清晰提示，可能涉及重要信息披露不充分或误导性展示。</a:t>
+              <a:t>《民法典》第500条要求遵守订约诚信；如故意隐瞒与订立合同有关的重要事实并造成损失，可能承担赔偿责任。</a:t>
             </a:r>
           </a:p>
         </p:txBody>
@@ -4877,7 +4877,7 @@
                 <a:ea typeface="Alibaba PuHuiTi 3.0"/>
                 <a:cs typeface="Alibaba PuHuiTi 3.0"/>
               </a:rPr>
-              <a:t>开发商需要书面说明并承担责任</a:t>
+              <a:t>宣传承诺与设计变更，均有规则约束</a:t>
             </a:r>
           </a:p>
         </p:txBody>
@@ -4899,7 +4899,7 @@
         <p:spPr>
           <a:xfrm xmlns:a="http://schemas.openxmlformats.org/drawingml/2006/main">
             <a:off x="2095500" y="5334000"/>
-            <a:ext cx="8572500" cy="781050"/>
+            <a:ext cx="8572500" cy="857250"/>
           </a:xfrm>
           <a:prstGeom xmlns:a="http://schemas.openxmlformats.org/drawingml/2006/main" prst="rect">
             <a:avLst/>
@@ -4935,7 +4935,7 @@
                 <a:ea typeface="Alibaba PuHuiTi 3.0"/>
                 <a:cs typeface="Alibaba PuHuiTi 3.0"/>
               </a:rPr>
-              <a:t>请说明相关限制的知悉时间及销售告知情况，提交书面整改方案，并提出品质补救及补偿安排。最终责任认定以合同、宣传材料、审批文件及主管部门意见为准。</a:t>
+              <a:t>商品房买卖司法解释第3条关注具体销售说明和允诺；《商品房销售管理办法》第24条涉及规划、设计变更通知义务。具体适用以合同、宣传材料、审批文件及实际影响为准。</a:t>
             </a:r>
           </a:p>
         </p:txBody>

</xml_diff>

<commit_message>
Add sales model evidence to entrance presentation
Signed-off-by: JW Design <jwcesign@cloudpilot.ai>
</commit_message>
<xml_diff>
--- a/files/project-entrance-owner-opinion.pptx
+++ b/files/project-entrance-owner-opinion.pptx
@@ -2,18 +2,19 @@
 <file path=ppt/presentation.xml><?xml version="1.0" encoding="utf-8"?>
 <p:presentation xmlns:p="http://schemas.openxmlformats.org/presentationml/2006/main">
   <p:sldMasterIdLst>
-    <p:sldMasterId xmlns:r="http://schemas.openxmlformats.org/officeDocument/2006/relationships" id="2147483648" r:id="Rf7818533dafa4619"/>
+    <p:sldMasterId xmlns:r="http://schemas.openxmlformats.org/officeDocument/2006/relationships" id="2147483648" r:id="R8664dc6fc6834c93"/>
   </p:sldMasterIdLst>
   <p:notesMasterIdLst>
-    <p:notesMasterId xmlns:r="http://schemas.openxmlformats.org/officeDocument/2006/relationships" r:id="Rcf0994594ec849e9"/>
+    <p:notesMasterId xmlns:r="http://schemas.openxmlformats.org/officeDocument/2006/relationships" r:id="R61f9678adfe348e1"/>
   </p:notesMasterIdLst>
   <p:sldIdLst>
-    <p:sldId xmlns:r="http://schemas.openxmlformats.org/officeDocument/2006/relationships" id="256" r:id="Rfaeec79eef9c4b33"/>
-    <p:sldId xmlns:r="http://schemas.openxmlformats.org/officeDocument/2006/relationships" id="257" r:id="Rd8f552b0b9c34fb1"/>
-    <p:sldId xmlns:r="http://schemas.openxmlformats.org/officeDocument/2006/relationships" id="258" r:id="Rb04b5df9a0844e1c"/>
-    <p:sldId xmlns:r="http://schemas.openxmlformats.org/officeDocument/2006/relationships" id="259" r:id="Rf0935cc08add4acf"/>
-    <p:sldId xmlns:r="http://schemas.openxmlformats.org/officeDocument/2006/relationships" id="260" r:id="Rd3220641fa0141dc"/>
-    <p:sldId xmlns:r="http://schemas.openxmlformats.org/officeDocument/2006/relationships" id="261" r:id="R14d2e0875c0a434f"/>
+    <p:sldId xmlns:r="http://schemas.openxmlformats.org/officeDocument/2006/relationships" id="256" r:id="R77244995ca574a12"/>
+    <p:sldId xmlns:r="http://schemas.openxmlformats.org/officeDocument/2006/relationships" id="257" r:id="R4defc166432047b5"/>
+    <p:sldId xmlns:r="http://schemas.openxmlformats.org/officeDocument/2006/relationships" id="258" r:id="Rdac670b57bc54a57"/>
+    <p:sldId xmlns:r="http://schemas.openxmlformats.org/officeDocument/2006/relationships" id="259" r:id="Rb00a1ac504114273"/>
+    <p:sldId xmlns:r="http://schemas.openxmlformats.org/officeDocument/2006/relationships" id="260" r:id="Ra174cfc937df4b1f"/>
+    <p:sldId xmlns:r="http://schemas.openxmlformats.org/officeDocument/2006/relationships" id="261" r:id="Rf0f92c2888774c22"/>
+    <p:sldId xmlns:r="http://schemas.openxmlformats.org/officeDocument/2006/relationships" id="262" r:id="Rbd0693c78a194234"/>
   </p:sldIdLst>
   <p:sldSz cx="12192000" cy="6858000"/>
   <p:notesSz cx="6858000" cy="9144000"/>
@@ -657,7 +658,7 @@
           <a:lstStyle xmlns:a="http://schemas.openxmlformats.org/drawingml/2006/main"/>
           <a:p xmlns:a="http://schemas.openxmlformats.org/drawingml/2006/main">
             <a:r>
-              <a:t>本页列明初步法律依据：一、《中华人民共和国民法典》第五百条规定订约阶段故意隐瞒与订立合同有关的重要事实、提供虚假情况或者有其他违背诚信原则的行为，造成对方损失的，应承担赔偿责任。二、《最高人民法院关于审理商品房买卖合同纠纷案件适用法律若干问题的解释》第三条规定，对开发规划范围内房屋及相关设施作出的具体说明和允诺，如对合同订立及价格有重大影响，可以构成合同内容。三、《商品房销售管理办法》第二十四条规定，特定规划、设计变更影响商品房质量或者使用功能时，开发企业负有书面通知义务。上述规则是否适用于本项目及责任范围，仍应结合合同、宣传材料、审批文件、实际影响及主管部门意见认定。</a:t>
+              <a:t>图片由业主提供，展示销售现场沙盘中的临街入口。该入口采用横向门廊和较大尺度雨棚。业主认为其与目前掌握的大门方案存在差异，请开发商书面说明沙盘对应的方案版本、调整时间和销售阶段告知情况。具体差异及责任认定，以开发商书面方案、审批图纸、销售材料和最终实施为准。</a:t>
             </a:r>
           </a:p>
         </p:txBody>
@@ -727,7 +728,7 @@
           <a:lstStyle xmlns:a="http://schemas.openxmlformats.org/drawingml/2006/main"/>
           <a:p xmlns:a="http://schemas.openxmlformats.org/drawingml/2006/main">
             <a:r>
-              <a:t>整改方案应在合法红线范围内尽量保留原销售展示所体现的入口品质。若整改导致原有效果无法实现，开发商应提出等效品质提升或合理补偿方案，并与业主正式协商。</a:t>
+              <a:t>本页列明初步法律依据：一、《中华人民共和国民法典》第五百条规定订约阶段故意隐瞒与订立合同有关的重要事实、提供虚假情况或者有其他违背诚信原则的行为，造成对方损失的，应承担赔偿责任。二、《最高人民法院关于审理商品房买卖合同纠纷案件适用法律若干问题的解释》第三条规定，对开发规划范围内房屋及相关设施作出的具体说明和允诺，如对合同订立及价格有重大影响，可以构成合同内容。三、《商品房销售管理办法》第二十四条规定，特定规划、设计变更影响商品房质量或者使用功能时，开发企业负有书面通知义务。上述规则是否适用于本项目及责任范围，仍应结合合同、宣传材料、审批文件、实际影响及主管部门意见认定。</a:t>
             </a:r>
           </a:p>
         </p:txBody>
@@ -758,6 +759,76 @@
 </file>
 
 <file path=ppt/notesSlides/notesSlide6.xml><?xml version="1.0" encoding="utf-8"?>
+<p:notes xmlns:p="http://schemas.openxmlformats.org/presentationml/2006/main">
+  <p:cSld>
+    <p:spTree>
+      <p:nvGrpSpPr>
+        <p:cNvPr id="1" name=""/>
+        <p:cNvGrpSpPr/>
+        <p:nvPr/>
+      </p:nvGrpSpPr>
+      <p:grpSpPr>
+        <a:xfrm xmlns:a="http://schemas.openxmlformats.org/drawingml/2006/main"/>
+      </p:grpSpPr>
+      <p:sp>
+        <p:nvSpPr>
+          <p:cNvPr id="2" name="Slide Image Placeholder 1"/>
+          <p:cNvSpPr>
+            <a:spLocks xmlns:a="http://schemas.openxmlformats.org/drawingml/2006/main" noGrp="1"/>
+          </p:cNvSpPr>
+          <p:nvPr>
+            <p:ph type="sldImg" idx="0"/>
+          </p:nvPr>
+        </p:nvSpPr>
+        <p:spPr/>
+      </p:sp>
+      <p:sp>
+        <p:nvSpPr>
+          <p:cNvPr id="3" name="Notes Placeholder 2"/>
+          <p:cNvSpPr>
+            <a:spLocks xmlns:a="http://schemas.openxmlformats.org/drawingml/2006/main" noGrp="1"/>
+          </p:cNvSpPr>
+          <p:nvPr>
+            <p:ph type="body" idx="1"/>
+          </p:nvPr>
+        </p:nvSpPr>
+        <p:spPr/>
+        <p:txBody>
+          <a:bodyPr xmlns:a="http://schemas.openxmlformats.org/drawingml/2006/main"/>
+          <a:lstStyle xmlns:a="http://schemas.openxmlformats.org/drawingml/2006/main"/>
+          <a:p xmlns:a="http://schemas.openxmlformats.org/drawingml/2006/main">
+            <a:r>
+              <a:t>整改方案应在合法红线范围内尽量保留原销售展示所体现的入口品质。若整改导致原有效果无法实现，开发商应提出等效品质提升或合理补偿方案，并与业主正式协商。</a:t>
+            </a:r>
+          </a:p>
+        </p:txBody>
+      </p:sp>
+      <p:sp>
+        <p:nvSpPr>
+          <p:cNvPr id="4" name="Slide Number Placeholder 3"/>
+          <p:cNvSpPr>
+            <a:spLocks xmlns:a="http://schemas.openxmlformats.org/drawingml/2006/main" noGrp="1"/>
+          </p:cNvSpPr>
+          <p:nvPr>
+            <p:ph type="sldNum" idx="5"/>
+          </p:nvPr>
+        </p:nvSpPr>
+        <p:spPr/>
+        <p:txBody>
+          <a:bodyPr xmlns:a="http://schemas.openxmlformats.org/drawingml/2006/main"/>
+          <a:lstStyle xmlns:a="http://schemas.openxmlformats.org/drawingml/2006/main"/>
+          <a:p xmlns:a="http://schemas.openxmlformats.org/drawingml/2006/main"/>
+        </p:txBody>
+      </p:sp>
+    </p:spTree>
+  </p:cSld>
+  <p:clrMapOvr>
+    <a:masterClrMapping xmlns:a="http://schemas.openxmlformats.org/drawingml/2006/main"/>
+  </p:clrMapOvr>
+</p:notes>
+</file>
+
+<file path=ppt/notesSlides/notesSlide7.xml><?xml version="1.0" encoding="utf-8"?>
 <p:notes xmlns:p="http://schemas.openxmlformats.org/presentationml/2006/main">
   <p:cSld>
     <p:spTree>
@@ -2665,12 +2736,12 @@
   </p:cSld>
   <p:clrMap bg1="lt1" tx1="dk1" bg2="lt2" tx2="dk2" accent1="accent1" accent2="accent2" accent3="accent3" accent4="accent4" accent5="accent5" accent6="accent6" hlink="hlink" folHlink="folHlink"/>
   <p:sldLayoutIdLst>
-    <p:sldLayoutId xmlns:r="http://schemas.openxmlformats.org/officeDocument/2006/relationships" id="2147483649" r:id="R28fd7e038da34cb4"/>
-    <p:sldLayoutId xmlns:r="http://schemas.openxmlformats.org/officeDocument/2006/relationships" id="2147483650" r:id="Rb6ebf7ac54e44319"/>
-    <p:sldLayoutId xmlns:r="http://schemas.openxmlformats.org/officeDocument/2006/relationships" id="2147483651" r:id="Racabd0ebb99b460b"/>
-    <p:sldLayoutId xmlns:r="http://schemas.openxmlformats.org/officeDocument/2006/relationships" id="2147483652" r:id="R5a671ec4df494fe2"/>
-    <p:sldLayoutId xmlns:r="http://schemas.openxmlformats.org/officeDocument/2006/relationships" id="2147483653" r:id="R55203828fe1f4938"/>
-    <p:sldLayoutId xmlns:r="http://schemas.openxmlformats.org/officeDocument/2006/relationships" id="2147483654" r:id="Rcb6542d61359400f"/>
+    <p:sldLayoutId xmlns:r="http://schemas.openxmlformats.org/officeDocument/2006/relationships" id="2147483649" r:id="R96d00f4be0a84f3d"/>
+    <p:sldLayoutId xmlns:r="http://schemas.openxmlformats.org/officeDocument/2006/relationships" id="2147483650" r:id="R3663809aa27c435e"/>
+    <p:sldLayoutId xmlns:r="http://schemas.openxmlformats.org/officeDocument/2006/relationships" id="2147483651" r:id="R7415a8bc402b4dd4"/>
+    <p:sldLayoutId xmlns:r="http://schemas.openxmlformats.org/officeDocument/2006/relationships" id="2147483652" r:id="R916bc936f9cf4c15"/>
+    <p:sldLayoutId xmlns:r="http://schemas.openxmlformats.org/officeDocument/2006/relationships" id="2147483653" r:id="R1677390c14f6423d"/>
+    <p:sldLayoutId xmlns:r="http://schemas.openxmlformats.org/officeDocument/2006/relationships" id="2147483654" r:id="R2407b49223664b78"/>
   </p:sldLayoutIdLst>
   <p:txStyles>
     <p:titleStyle>
@@ -3225,7 +3296,7 @@
           <p:nvPr/>
         </p:nvPicPr>
         <p:blipFill>
-          <a:blip xmlns:r="http://schemas.openxmlformats.org/officeDocument/2006/relationships" xmlns:a="http://schemas.openxmlformats.org/drawingml/2006/main" r:embed="Rd4445781180d4e29"/>
+          <a:blip xmlns:r="http://schemas.openxmlformats.org/officeDocument/2006/relationships" xmlns:a="http://schemas.openxmlformats.org/drawingml/2006/main" r:embed="R7d59faedcd054ed2"/>
           <a:srcRect xmlns:a="http://schemas.openxmlformats.org/drawingml/2006/main" l="0" t="0" r="0" b="0"/>
           <a:stretch xmlns:a="http://schemas.openxmlformats.org/drawingml/2006/main">
             <a:fillRect l="0" t="0" r="0" b="0"/>
@@ -4028,7 +4099,7 @@
           <p:nvPr/>
         </p:nvPicPr>
         <p:blipFill>
-          <a:blip xmlns:r="http://schemas.openxmlformats.org/officeDocument/2006/relationships" xmlns:a="http://schemas.openxmlformats.org/drawingml/2006/main" r:embed="R69084ef51d2d4268"/>
+          <a:blip xmlns:r="http://schemas.openxmlformats.org/officeDocument/2006/relationships" xmlns:a="http://schemas.openxmlformats.org/drawingml/2006/main" r:embed="Rbcb83d2e8681461c"/>
           <a:stretch xmlns:a="http://schemas.openxmlformats.org/drawingml/2006/main"/>
         </p:blipFill>
         <p:spPr>
@@ -4284,6 +4355,660 @@
 </file>
 
 <file path=ppt/slides/slide4.xml><?xml version="1.0" encoding="utf-8"?>
+<p:sld xmlns:p="http://schemas.openxmlformats.org/presentationml/2006/main">
+  <p:cSld>
+    <p:bg>
+      <p:bgPr>
+        <a:solidFill xmlns:a="http://schemas.openxmlformats.org/drawingml/2006/main">
+          <a:srgbClr val="FBFAF7"/>
+        </a:solidFill>
+      </p:bgPr>
+    </p:bg>
+    <p:spTree>
+      <p:nvGrpSpPr>
+        <p:cNvPr id="1" name=""/>
+        <p:cNvGrpSpPr/>
+        <p:nvPr/>
+      </p:nvGrpSpPr>
+      <p:grpSpPr>
+        <a:xfrm xmlns:a="http://schemas.openxmlformats.org/drawingml/2006/main"/>
+      </p:grpSpPr>
+      <p:sp>
+        <p:nvSpPr>
+          <p:cNvPr id="13" name="">
+            <a:extLst xmlns:a="http://schemas.openxmlformats.org/drawingml/2006/main">
+              <a:ext uri="{FF2B5EF4-FFF2-40B4-BE49-F238E27FC236}">
+                <a16:creationId xmlns:a16="http://schemas.microsoft.com/office/drawing/2014/main" id="{AC0CD9EE-D074-4F91-9390-1B660E8F3E34}"/>
+              </a:ext>
+            </a:extLst>
+          </p:cNvPr>
+          <p:cNvSpPr>
+            <a:spLocks xmlns:a="http://schemas.openxmlformats.org/drawingml/2006/main" noGrp="1"/>
+          </p:cNvSpPr>
+          <p:nvPr/>
+        </p:nvSpPr>
+        <p:spPr>
+          <a:xfrm xmlns:a="http://schemas.openxmlformats.org/drawingml/2006/main">
+            <a:off x="781050" y="495300"/>
+            <a:ext cx="666750" cy="266700"/>
+          </a:xfrm>
+          <a:prstGeom xmlns:a="http://schemas.openxmlformats.org/drawingml/2006/main" prst="rect">
+            <a:avLst/>
+          </a:prstGeom>
+          <a:noFill xmlns:a="http://schemas.openxmlformats.org/drawingml/2006/main"/>
+          <a:ln xmlns:a="http://schemas.openxmlformats.org/drawingml/2006/main" w="0">
+            <a:noFill/>
+          </a:ln>
+        </p:spPr>
+        <p:txBody>
+          <a:bodyPr xmlns:a="http://schemas.openxmlformats.org/drawingml/2006/main" wrap="square" lIns="0" tIns="0" rIns="0" bIns="0" anchor="t">
+            <a:noAutofit/>
+          </a:bodyPr>
+          <a:lstStyle xmlns:a="http://schemas.openxmlformats.org/drawingml/2006/main"/>
+          <a:p xmlns:a="http://schemas.openxmlformats.org/drawingml/2006/main">
+            <a:pPr algn="l">
+              <a:defRPr sz="1350" b="1">
+                <a:solidFill>
+                  <a:srgbClr val="A8895E"/>
+                </a:solidFill>
+                <a:latin typeface="Alibaba PuHuiTi 3.0"/>
+                <a:ea typeface="Alibaba PuHuiTi 3.0"/>
+                <a:cs typeface="Alibaba PuHuiTi 3.0"/>
+              </a:defRPr>
+            </a:pPr>
+            <a:r>
+              <a:rPr sz="1350" b="1">
+                <a:solidFill>
+                  <a:srgbClr val="A8895E"/>
+                </a:solidFill>
+                <a:latin typeface="Alibaba PuHuiTi 3.0"/>
+                <a:ea typeface="Alibaba PuHuiTi 3.0"/>
+                <a:cs typeface="Alibaba PuHuiTi 3.0"/>
+              </a:rPr>
+              <a:t>03</a:t>
+            </a:r>
+          </a:p>
+        </p:txBody>
+      </p:sp>
+      <p:sp>
+        <p:nvSpPr>
+          <p:cNvPr id="2" name="">
+            <a:extLst xmlns:a="http://schemas.openxmlformats.org/drawingml/2006/main">
+              <a:ext uri="{FF2B5EF4-FFF2-40B4-BE49-F238E27FC236}">
+                <a16:creationId xmlns:a16="http://schemas.microsoft.com/office/drawing/2014/main" id="{E936F430-6D1E-4E57-8092-F22E9F1045E7}"/>
+              </a:ext>
+            </a:extLst>
+          </p:cNvPr>
+          <p:cNvSpPr>
+            <a:spLocks xmlns:a="http://schemas.openxmlformats.org/drawingml/2006/main" noGrp="1"/>
+          </p:cNvSpPr>
+          <p:nvPr/>
+        </p:nvSpPr>
+        <p:spPr>
+          <a:xfrm xmlns:a="http://schemas.openxmlformats.org/drawingml/2006/main">
+            <a:off x="781050" y="857250"/>
+            <a:ext cx="10572750" cy="666750"/>
+          </a:xfrm>
+          <a:prstGeom xmlns:a="http://schemas.openxmlformats.org/drawingml/2006/main" prst="rect">
+            <a:avLst/>
+          </a:prstGeom>
+          <a:noFill xmlns:a="http://schemas.openxmlformats.org/drawingml/2006/main"/>
+          <a:ln xmlns:a="http://schemas.openxmlformats.org/drawingml/2006/main" w="0">
+            <a:noFill/>
+          </a:ln>
+        </p:spPr>
+        <p:txBody>
+          <a:bodyPr xmlns:a="http://schemas.openxmlformats.org/drawingml/2006/main" wrap="square" lIns="0" tIns="0" rIns="0" bIns="0" anchor="t">
+            <a:noAutofit/>
+          </a:bodyPr>
+          <a:lstStyle xmlns:a="http://schemas.openxmlformats.org/drawingml/2006/main"/>
+          <a:p xmlns:a="http://schemas.openxmlformats.org/drawingml/2006/main">
+            <a:pPr algn="l">
+              <a:defRPr sz="3150" b="1">
+                <a:solidFill>
+                  <a:srgbClr val="202824"/>
+                </a:solidFill>
+                <a:latin typeface="Alibaba PuHuiTi 3.0"/>
+                <a:ea typeface="Alibaba PuHuiTi 3.0"/>
+                <a:cs typeface="Alibaba PuHuiTi 3.0"/>
+              </a:defRPr>
+            </a:pPr>
+            <a:r>
+              <a:rPr sz="3150" b="1">
+                <a:solidFill>
+                  <a:srgbClr val="202824"/>
+                </a:solidFill>
+                <a:latin typeface="Alibaba PuHuiTi 3.0"/>
+                <a:ea typeface="Alibaba PuHuiTi 3.0"/>
+                <a:cs typeface="Alibaba PuHuiTi 3.0"/>
+              </a:rPr>
+              <a:t>销售沙盘展示与目前大门方案存在差异</a:t>
+            </a:r>
+          </a:p>
+        </p:txBody>
+      </p:sp>
+      <p:pic>
+        <p:nvPicPr>
+          <p:cNvPr id="15" name=""/>
+          <p:cNvPicPr>
+            <a:picLocks xmlns:a="http://schemas.openxmlformats.org/drawingml/2006/main" noChangeAspect="1"/>
+          </p:cNvPicPr>
+          <p:nvPr/>
+        </p:nvPicPr>
+        <p:blipFill>
+          <a:blip xmlns:r="http://schemas.openxmlformats.org/officeDocument/2006/relationships" xmlns:a="http://schemas.openxmlformats.org/drawingml/2006/main" r:embed="Rbca3b9d8f8aa4d9a"/>
+          <a:srcRect xmlns:a="http://schemas.openxmlformats.org/drawingml/2006/main" l="0" t="6000" r="0" b="6000"/>
+          <a:stretch xmlns:a="http://schemas.openxmlformats.org/drawingml/2006/main"/>
+        </p:blipFill>
+        <p:spPr>
+          <a:xfrm xmlns:a="http://schemas.openxmlformats.org/drawingml/2006/main">
+            <a:off x="781050" y="1666875"/>
+            <a:ext cx="6858000" cy="4429125"/>
+          </a:xfrm>
+          <a:prstGeom xmlns:a="http://schemas.openxmlformats.org/drawingml/2006/main" prst="rect">
+            <a:avLst/>
+          </a:prstGeom>
+        </p:spPr>
+      </p:pic>
+      <p:sp>
+        <p:nvSpPr>
+          <p:cNvPr id="4" name="">
+            <a:extLst xmlns:a="http://schemas.openxmlformats.org/drawingml/2006/main">
+              <a:ext uri="{FF2B5EF4-FFF2-40B4-BE49-F238E27FC236}">
+                <a16:creationId xmlns:a16="http://schemas.microsoft.com/office/drawing/2014/main" id="{A04597F0-220C-42B1-9E93-437DF3CF25D3}"/>
+              </a:ext>
+            </a:extLst>
+          </p:cNvPr>
+          <p:cNvSpPr>
+            <a:spLocks xmlns:a="http://schemas.openxmlformats.org/drawingml/2006/main" noGrp="1"/>
+          </p:cNvSpPr>
+          <p:nvPr/>
+        </p:nvSpPr>
+        <p:spPr>
+          <a:xfrm xmlns:a="http://schemas.openxmlformats.org/drawingml/2006/main">
+            <a:off x="971550" y="4000500"/>
+            <a:ext cx="2781300" cy="1657350"/>
+          </a:xfrm>
+          <a:prstGeom xmlns:a="http://schemas.openxmlformats.org/drawingml/2006/main" prst="roundRect">
+            <a:avLst>
+              <a:gd name="adj" fmla="val 4598"/>
+            </a:avLst>
+          </a:prstGeom>
+          <a:noFill xmlns:a="http://schemas.openxmlformats.org/drawingml/2006/main"/>
+          <a:ln xmlns:a="http://schemas.openxmlformats.org/drawingml/2006/main" w="28575">
+            <a:solidFill>
+              <a:srgbClr val="A8895E"/>
+            </a:solidFill>
+          </a:ln>
+        </p:spPr>
+      </p:sp>
+      <p:sp>
+        <p:nvSpPr>
+          <p:cNvPr id="5" name="">
+            <a:extLst xmlns:a="http://schemas.openxmlformats.org/drawingml/2006/main">
+              <a:ext uri="{FF2B5EF4-FFF2-40B4-BE49-F238E27FC236}">
+                <a16:creationId xmlns:a16="http://schemas.microsoft.com/office/drawing/2014/main" id="{A50BDC3B-D7EF-42D6-B2F2-094DDE77F13F}"/>
+              </a:ext>
+            </a:extLst>
+          </p:cNvPr>
+          <p:cNvSpPr>
+            <a:spLocks xmlns:a="http://schemas.openxmlformats.org/drawingml/2006/main" noGrp="1"/>
+          </p:cNvSpPr>
+          <p:nvPr/>
+        </p:nvSpPr>
+        <p:spPr>
+          <a:xfrm xmlns:a="http://schemas.openxmlformats.org/drawingml/2006/main">
+            <a:off x="781050" y="6153150"/>
+            <a:ext cx="6858000" cy="171450"/>
+          </a:xfrm>
+          <a:prstGeom xmlns:a="http://schemas.openxmlformats.org/drawingml/2006/main" prst="rect">
+            <a:avLst/>
+          </a:prstGeom>
+          <a:noFill xmlns:a="http://schemas.openxmlformats.org/drawingml/2006/main"/>
+          <a:ln xmlns:a="http://schemas.openxmlformats.org/drawingml/2006/main" w="0">
+            <a:noFill/>
+          </a:ln>
+        </p:spPr>
+        <p:txBody>
+          <a:bodyPr xmlns:a="http://schemas.openxmlformats.org/drawingml/2006/main" wrap="square" lIns="0" tIns="0" rIns="0" bIns="0" anchor="t">
+            <a:noAutofit/>
+          </a:bodyPr>
+          <a:lstStyle xmlns:a="http://schemas.openxmlformats.org/drawingml/2006/main"/>
+          <a:p xmlns:a="http://schemas.openxmlformats.org/drawingml/2006/main">
+            <a:pPr algn="l">
+              <a:defRPr sz="1050" b="0">
+                <a:solidFill>
+                  <a:srgbClr val="526159"/>
+                </a:solidFill>
+                <a:latin typeface="Alibaba PuHuiTi 3.0"/>
+                <a:ea typeface="Alibaba PuHuiTi 3.0"/>
+                <a:cs typeface="Alibaba PuHuiTi 3.0"/>
+              </a:defRPr>
+            </a:pPr>
+            <a:r>
+              <a:rPr sz="1050" b="0">
+                <a:solidFill>
+                  <a:srgbClr val="526159"/>
+                </a:solidFill>
+                <a:latin typeface="Alibaba PuHuiTi 3.0"/>
+                <a:ea typeface="Alibaba PuHuiTi 3.0"/>
+                <a:cs typeface="Alibaba PuHuiTi 3.0"/>
+              </a:rPr>
+              <a:t>金色框为业主标注，仅用于指出沙盘中的临街入口。</a:t>
+            </a:r>
+          </a:p>
+        </p:txBody>
+      </p:sp>
+      <p:sp>
+        <p:nvSpPr>
+          <p:cNvPr id="6" name="">
+            <a:extLst xmlns:a="http://schemas.openxmlformats.org/drawingml/2006/main">
+              <a:ext uri="{FF2B5EF4-FFF2-40B4-BE49-F238E27FC236}">
+                <a16:creationId xmlns:a16="http://schemas.microsoft.com/office/drawing/2014/main" id="{AD51D037-B96C-4947-8AC4-B8206091395D}"/>
+              </a:ext>
+            </a:extLst>
+          </p:cNvPr>
+          <p:cNvSpPr>
+            <a:spLocks xmlns:a="http://schemas.openxmlformats.org/drawingml/2006/main" noGrp="1"/>
+          </p:cNvSpPr>
+          <p:nvPr/>
+        </p:nvSpPr>
+        <p:spPr>
+          <a:xfrm xmlns:a="http://schemas.openxmlformats.org/drawingml/2006/main">
+            <a:off x="8096250" y="1809750"/>
+            <a:ext cx="3143250" cy="304800"/>
+          </a:xfrm>
+          <a:prstGeom xmlns:a="http://schemas.openxmlformats.org/drawingml/2006/main" prst="rect">
+            <a:avLst/>
+          </a:prstGeom>
+          <a:noFill xmlns:a="http://schemas.openxmlformats.org/drawingml/2006/main"/>
+          <a:ln xmlns:a="http://schemas.openxmlformats.org/drawingml/2006/main" w="0">
+            <a:noFill/>
+          </a:ln>
+        </p:spPr>
+        <p:txBody>
+          <a:bodyPr xmlns:a="http://schemas.openxmlformats.org/drawingml/2006/main" wrap="square" lIns="0" tIns="0" rIns="0" bIns="0" anchor="t">
+            <a:noAutofit/>
+          </a:bodyPr>
+          <a:lstStyle xmlns:a="http://schemas.openxmlformats.org/drawingml/2006/main"/>
+          <a:p xmlns:a="http://schemas.openxmlformats.org/drawingml/2006/main">
+            <a:pPr algn="l">
+              <a:defRPr sz="1500" b="1">
+                <a:solidFill>
+                  <a:srgbClr val="A8895E"/>
+                </a:solidFill>
+                <a:latin typeface="Alibaba PuHuiTi 3.0"/>
+                <a:ea typeface="Alibaba PuHuiTi 3.0"/>
+                <a:cs typeface="Alibaba PuHuiTi 3.0"/>
+              </a:defRPr>
+            </a:pPr>
+            <a:r>
+              <a:rPr sz="1500" b="1">
+                <a:solidFill>
+                  <a:srgbClr val="A8895E"/>
+                </a:solidFill>
+                <a:latin typeface="Alibaba PuHuiTi 3.0"/>
+                <a:ea typeface="Alibaba PuHuiTi 3.0"/>
+                <a:cs typeface="Alibaba PuHuiTi 3.0"/>
+              </a:rPr>
+              <a:t>沙盘展示</a:t>
+            </a:r>
+          </a:p>
+        </p:txBody>
+      </p:sp>
+      <p:sp>
+        <p:nvSpPr>
+          <p:cNvPr id="7" name="">
+            <a:extLst xmlns:a="http://schemas.openxmlformats.org/drawingml/2006/main">
+              <a:ext uri="{FF2B5EF4-FFF2-40B4-BE49-F238E27FC236}">
+                <a16:creationId xmlns:a16="http://schemas.microsoft.com/office/drawing/2014/main" id="{82FD10F8-976C-434B-A62A-92F8DE8A4C9B}"/>
+              </a:ext>
+            </a:extLst>
+          </p:cNvPr>
+          <p:cNvSpPr>
+            <a:spLocks xmlns:a="http://schemas.openxmlformats.org/drawingml/2006/main" noGrp="1"/>
+          </p:cNvSpPr>
+          <p:nvPr/>
+        </p:nvSpPr>
+        <p:spPr>
+          <a:xfrm xmlns:a="http://schemas.openxmlformats.org/drawingml/2006/main">
+            <a:off x="8096250" y="2209800"/>
+            <a:ext cx="3257550" cy="990600"/>
+          </a:xfrm>
+          <a:prstGeom xmlns:a="http://schemas.openxmlformats.org/drawingml/2006/main" prst="rect">
+            <a:avLst/>
+          </a:prstGeom>
+          <a:noFill xmlns:a="http://schemas.openxmlformats.org/drawingml/2006/main"/>
+          <a:ln xmlns:a="http://schemas.openxmlformats.org/drawingml/2006/main" w="0">
+            <a:noFill/>
+          </a:ln>
+        </p:spPr>
+        <p:txBody>
+          <a:bodyPr xmlns:a="http://schemas.openxmlformats.org/drawingml/2006/main" wrap="square" lIns="0" tIns="0" rIns="0" bIns="0" anchor="t">
+            <a:noAutofit/>
+          </a:bodyPr>
+          <a:lstStyle xmlns:a="http://schemas.openxmlformats.org/drawingml/2006/main"/>
+          <a:p xmlns:a="http://schemas.openxmlformats.org/drawingml/2006/main">
+            <a:pPr algn="l">
+              <a:defRPr sz="2325" b="1">
+                <a:solidFill>
+                  <a:srgbClr val="202824"/>
+                </a:solidFill>
+                <a:latin typeface="Alibaba PuHuiTi 3.0"/>
+                <a:ea typeface="Alibaba PuHuiTi 3.0"/>
+                <a:cs typeface="Alibaba PuHuiTi 3.0"/>
+              </a:defRPr>
+            </a:pPr>
+            <a:r>
+              <a:rPr sz="2325" b="1">
+                <a:solidFill>
+                  <a:srgbClr val="202824"/>
+                </a:solidFill>
+                <a:latin typeface="Alibaba PuHuiTi 3.0"/>
+                <a:ea typeface="Alibaba PuHuiTi 3.0"/>
+                <a:cs typeface="Alibaba PuHuiTi 3.0"/>
+              </a:rPr>
+              <a:t>临街入口形成明确门廊，雨棚尺度突出</a:t>
+            </a:r>
+          </a:p>
+        </p:txBody>
+      </p:sp>
+      <p:sp>
+        <p:nvSpPr>
+          <p:cNvPr id="8" name="">
+            <a:extLst xmlns:a="http://schemas.openxmlformats.org/drawingml/2006/main">
+              <a:ext uri="{FF2B5EF4-FFF2-40B4-BE49-F238E27FC236}">
+                <a16:creationId xmlns:a16="http://schemas.microsoft.com/office/drawing/2014/main" id="{59CB3DEA-517A-4290-8841-2CD330246538}"/>
+              </a:ext>
+            </a:extLst>
+          </p:cNvPr>
+          <p:cNvSpPr>
+            <a:spLocks xmlns:a="http://schemas.openxmlformats.org/drawingml/2006/main" noGrp="1"/>
+          </p:cNvSpPr>
+          <p:nvPr/>
+        </p:nvSpPr>
+        <p:spPr>
+          <a:xfrm xmlns:a="http://schemas.openxmlformats.org/drawingml/2006/main">
+            <a:off x="8096250" y="3429000"/>
+            <a:ext cx="3143250" cy="304800"/>
+          </a:xfrm>
+          <a:prstGeom xmlns:a="http://schemas.openxmlformats.org/drawingml/2006/main" prst="rect">
+            <a:avLst/>
+          </a:prstGeom>
+          <a:noFill xmlns:a="http://schemas.openxmlformats.org/drawingml/2006/main"/>
+          <a:ln xmlns:a="http://schemas.openxmlformats.org/drawingml/2006/main" w="0">
+            <a:noFill/>
+          </a:ln>
+        </p:spPr>
+        <p:txBody>
+          <a:bodyPr xmlns:a="http://schemas.openxmlformats.org/drawingml/2006/main" wrap="square" lIns="0" tIns="0" rIns="0" bIns="0" anchor="t">
+            <a:noAutofit/>
+          </a:bodyPr>
+          <a:lstStyle xmlns:a="http://schemas.openxmlformats.org/drawingml/2006/main"/>
+          <a:p xmlns:a="http://schemas.openxmlformats.org/drawingml/2006/main">
+            <a:pPr algn="l">
+              <a:defRPr sz="1500" b="1">
+                <a:solidFill>
+                  <a:srgbClr val="A8895E"/>
+                </a:solidFill>
+                <a:latin typeface="Alibaba PuHuiTi 3.0"/>
+                <a:ea typeface="Alibaba PuHuiTi 3.0"/>
+                <a:cs typeface="Alibaba PuHuiTi 3.0"/>
+              </a:defRPr>
+            </a:pPr>
+            <a:r>
+              <a:rPr sz="1500" b="1">
+                <a:solidFill>
+                  <a:srgbClr val="A8895E"/>
+                </a:solidFill>
+                <a:latin typeface="Alibaba PuHuiTi 3.0"/>
+                <a:ea typeface="Alibaba PuHuiTi 3.0"/>
+                <a:cs typeface="Alibaba PuHuiTi 3.0"/>
+              </a:rPr>
+              <a:t>目前掌握情况</a:t>
+            </a:r>
+          </a:p>
+        </p:txBody>
+      </p:sp>
+      <p:sp>
+        <p:nvSpPr>
+          <p:cNvPr id="9" name="">
+            <a:extLst xmlns:a="http://schemas.openxmlformats.org/drawingml/2006/main">
+              <a:ext uri="{FF2B5EF4-FFF2-40B4-BE49-F238E27FC236}">
+                <a16:creationId xmlns:a16="http://schemas.microsoft.com/office/drawing/2014/main" id="{5D7139CE-6924-4CF1-8A71-56B19853223C}"/>
+              </a:ext>
+            </a:extLst>
+          </p:cNvPr>
+          <p:cNvSpPr>
+            <a:spLocks xmlns:a="http://schemas.openxmlformats.org/drawingml/2006/main" noGrp="1"/>
+          </p:cNvSpPr>
+          <p:nvPr/>
+        </p:nvSpPr>
+        <p:spPr>
+          <a:xfrm xmlns:a="http://schemas.openxmlformats.org/drawingml/2006/main">
+            <a:off x="8096250" y="3829050"/>
+            <a:ext cx="3257550" cy="990600"/>
+          </a:xfrm>
+          <a:prstGeom xmlns:a="http://schemas.openxmlformats.org/drawingml/2006/main" prst="rect">
+            <a:avLst/>
+          </a:prstGeom>
+          <a:noFill xmlns:a="http://schemas.openxmlformats.org/drawingml/2006/main"/>
+          <a:ln xmlns:a="http://schemas.openxmlformats.org/drawingml/2006/main" w="0">
+            <a:noFill/>
+          </a:ln>
+        </p:spPr>
+        <p:txBody>
+          <a:bodyPr xmlns:a="http://schemas.openxmlformats.org/drawingml/2006/main" wrap="square" lIns="0" tIns="0" rIns="0" bIns="0" anchor="t">
+            <a:noAutofit/>
+          </a:bodyPr>
+          <a:lstStyle xmlns:a="http://schemas.openxmlformats.org/drawingml/2006/main"/>
+          <a:p xmlns:a="http://schemas.openxmlformats.org/drawingml/2006/main">
+            <a:pPr algn="l">
+              <a:defRPr sz="1500" b="0">
+                <a:solidFill>
+                  <a:srgbClr val="526159"/>
+                </a:solidFill>
+                <a:latin typeface="Alibaba PuHuiTi 3.0"/>
+                <a:ea typeface="Alibaba PuHuiTi 3.0"/>
+                <a:cs typeface="Alibaba PuHuiTi 3.0"/>
+              </a:defRPr>
+            </a:pPr>
+            <a:r>
+              <a:rPr sz="1500" b="0">
+                <a:solidFill>
+                  <a:srgbClr val="526159"/>
+                </a:solidFill>
+                <a:latin typeface="Alibaba PuHuiTi 3.0"/>
+                <a:ea typeface="Alibaba PuHuiTi 3.0"/>
+                <a:cs typeface="Alibaba PuHuiTi 3.0"/>
+              </a:rPr>
+              <a:t>据业主目前掌握材料，现阶段大门方案在形态、尺度和景观组织上与该展示不一致。</a:t>
+            </a:r>
+          </a:p>
+        </p:txBody>
+      </p:sp>
+      <p:sp>
+        <p:nvSpPr>
+          <p:cNvPr id="10" name="">
+            <a:extLst xmlns:a="http://schemas.openxmlformats.org/drawingml/2006/main">
+              <a:ext uri="{FF2B5EF4-FFF2-40B4-BE49-F238E27FC236}">
+                <a16:creationId xmlns:a16="http://schemas.microsoft.com/office/drawing/2014/main" id="{6BF2E8C8-19DA-477B-A86E-C690338CB664}"/>
+              </a:ext>
+            </a:extLst>
+          </p:cNvPr>
+          <p:cNvSpPr>
+            <a:spLocks xmlns:a="http://schemas.openxmlformats.org/drawingml/2006/main" noGrp="1"/>
+          </p:cNvSpPr>
+          <p:nvPr/>
+        </p:nvSpPr>
+        <p:spPr>
+          <a:xfrm xmlns:a="http://schemas.openxmlformats.org/drawingml/2006/main">
+            <a:off x="8096250" y="5048250"/>
+            <a:ext cx="3257550" cy="323850"/>
+          </a:xfrm>
+          <a:prstGeom xmlns:a="http://schemas.openxmlformats.org/drawingml/2006/main" prst="rect">
+            <a:avLst/>
+          </a:prstGeom>
+          <a:noFill xmlns:a="http://schemas.openxmlformats.org/drawingml/2006/main"/>
+          <a:ln xmlns:a="http://schemas.openxmlformats.org/drawingml/2006/main" w="0">
+            <a:noFill/>
+          </a:ln>
+        </p:spPr>
+        <p:txBody>
+          <a:bodyPr xmlns:a="http://schemas.openxmlformats.org/drawingml/2006/main" wrap="square" lIns="0" tIns="0" rIns="0" bIns="0" anchor="t">
+            <a:noAutofit/>
+          </a:bodyPr>
+          <a:lstStyle xmlns:a="http://schemas.openxmlformats.org/drawingml/2006/main"/>
+          <a:p xmlns:a="http://schemas.openxmlformats.org/drawingml/2006/main">
+            <a:pPr algn="l">
+              <a:defRPr sz="1725" b="1">
+                <a:solidFill>
+                  <a:srgbClr val="202824"/>
+                </a:solidFill>
+                <a:latin typeface="Alibaba PuHuiTi 3.0"/>
+                <a:ea typeface="Alibaba PuHuiTi 3.0"/>
+                <a:cs typeface="Alibaba PuHuiTi 3.0"/>
+              </a:defRPr>
+            </a:pPr>
+            <a:r>
+              <a:rPr sz="1725" b="1">
+                <a:solidFill>
+                  <a:srgbClr val="202824"/>
+                </a:solidFill>
+                <a:latin typeface="Alibaba PuHuiTi 3.0"/>
+                <a:ea typeface="Alibaba PuHuiTi 3.0"/>
+                <a:cs typeface="Alibaba PuHuiTi 3.0"/>
+              </a:rPr>
+              <a:t>请开发商书面说明</a:t>
+            </a:r>
+          </a:p>
+        </p:txBody>
+      </p:sp>
+      <p:sp>
+        <p:nvSpPr>
+          <p:cNvPr id="11" name="">
+            <a:extLst xmlns:a="http://schemas.openxmlformats.org/drawingml/2006/main">
+              <a:ext uri="{FF2B5EF4-FFF2-40B4-BE49-F238E27FC236}">
+                <a16:creationId xmlns:a16="http://schemas.microsoft.com/office/drawing/2014/main" id="{D570C7E9-3892-41DB-B9D0-588C4205488C}"/>
+              </a:ext>
+            </a:extLst>
+          </p:cNvPr>
+          <p:cNvSpPr>
+            <a:spLocks xmlns:a="http://schemas.openxmlformats.org/drawingml/2006/main" noGrp="1"/>
+          </p:cNvSpPr>
+          <p:nvPr/>
+        </p:nvSpPr>
+        <p:spPr>
+          <a:xfrm xmlns:a="http://schemas.openxmlformats.org/drawingml/2006/main">
+            <a:off x="8096250" y="5467350"/>
+            <a:ext cx="3257550" cy="628650"/>
+          </a:xfrm>
+          <a:prstGeom xmlns:a="http://schemas.openxmlformats.org/drawingml/2006/main" prst="rect">
+            <a:avLst/>
+          </a:prstGeom>
+          <a:noFill xmlns:a="http://schemas.openxmlformats.org/drawingml/2006/main"/>
+          <a:ln xmlns:a="http://schemas.openxmlformats.org/drawingml/2006/main" w="0">
+            <a:noFill/>
+          </a:ln>
+        </p:spPr>
+        <p:txBody>
+          <a:bodyPr xmlns:a="http://schemas.openxmlformats.org/drawingml/2006/main" wrap="square" lIns="0" tIns="0" rIns="0" bIns="0" anchor="t">
+            <a:noAutofit/>
+          </a:bodyPr>
+          <a:lstStyle xmlns:a="http://schemas.openxmlformats.org/drawingml/2006/main"/>
+          <a:p xmlns:a="http://schemas.openxmlformats.org/drawingml/2006/main">
+            <a:pPr algn="l">
+              <a:defRPr sz="1350" b="0">
+                <a:solidFill>
+                  <a:srgbClr val="526159"/>
+                </a:solidFill>
+                <a:latin typeface="Alibaba PuHuiTi 3.0"/>
+                <a:ea typeface="Alibaba PuHuiTi 3.0"/>
+                <a:cs typeface="Alibaba PuHuiTi 3.0"/>
+              </a:defRPr>
+            </a:pPr>
+            <a:r>
+              <a:rPr sz="1350" b="0">
+                <a:solidFill>
+                  <a:srgbClr val="526159"/>
+                </a:solidFill>
+                <a:latin typeface="Alibaba PuHuiTi 3.0"/>
+                <a:ea typeface="Alibaba PuHuiTi 3.0"/>
+                <a:cs typeface="Alibaba PuHuiTi 3.0"/>
+              </a:rPr>
+              <a:t>沙盘对应的方案版本、调整时间，以及销售阶段是否已向购房人明确告知。</a:t>
+            </a:r>
+          </a:p>
+        </p:txBody>
+      </p:sp>
+      <p:sp>
+        <p:nvSpPr>
+          <p:cNvPr id="12" name="">
+            <a:extLst xmlns:a="http://schemas.openxmlformats.org/drawingml/2006/main">
+              <a:ext uri="{FF2B5EF4-FFF2-40B4-BE49-F238E27FC236}">
+                <a16:creationId xmlns:a16="http://schemas.microsoft.com/office/drawing/2014/main" id="{0715F933-1483-4E35-B3FE-14B3DE1E0BDF}"/>
+              </a:ext>
+            </a:extLst>
+          </p:cNvPr>
+          <p:cNvSpPr>
+            <a:spLocks xmlns:a="http://schemas.openxmlformats.org/drawingml/2006/main" noGrp="1"/>
+          </p:cNvSpPr>
+          <p:nvPr/>
+        </p:nvSpPr>
+        <p:spPr>
+          <a:xfrm xmlns:a="http://schemas.openxmlformats.org/drawingml/2006/main">
+            <a:off x="781050" y="6419850"/>
+            <a:ext cx="10572750" cy="171450"/>
+          </a:xfrm>
+          <a:prstGeom xmlns:a="http://schemas.openxmlformats.org/drawingml/2006/main" prst="rect">
+            <a:avLst/>
+          </a:prstGeom>
+          <a:noFill xmlns:a="http://schemas.openxmlformats.org/drawingml/2006/main"/>
+          <a:ln xmlns:a="http://schemas.openxmlformats.org/drawingml/2006/main" w="0">
+            <a:noFill/>
+          </a:ln>
+        </p:spPr>
+        <p:txBody>
+          <a:bodyPr xmlns:a="http://schemas.openxmlformats.org/drawingml/2006/main" wrap="square" lIns="0" tIns="0" rIns="0" bIns="0" anchor="t">
+            <a:noAutofit/>
+          </a:bodyPr>
+          <a:lstStyle xmlns:a="http://schemas.openxmlformats.org/drawingml/2006/main"/>
+          <a:p xmlns:a="http://schemas.openxmlformats.org/drawingml/2006/main">
+            <a:pPr algn="r">
+              <a:defRPr sz="975" b="0">
+                <a:solidFill>
+                  <a:srgbClr val="526159"/>
+                </a:solidFill>
+                <a:latin typeface="Alibaba PuHuiTi 3.0"/>
+                <a:ea typeface="Alibaba PuHuiTi 3.0"/>
+                <a:cs typeface="Alibaba PuHuiTi 3.0"/>
+              </a:defRPr>
+            </a:pPr>
+            <a:r>
+              <a:rPr sz="975" b="0">
+                <a:solidFill>
+                  <a:srgbClr val="526159"/>
+                </a:solidFill>
+                <a:latin typeface="Alibaba PuHuiTi 3.0"/>
+                <a:ea typeface="Alibaba PuHuiTi 3.0"/>
+                <a:cs typeface="Alibaba PuHuiTi 3.0"/>
+              </a:rPr>
+              <a:t>项目主入口整改事项  04</a:t>
+            </a:r>
+          </a:p>
+        </p:txBody>
+      </p:sp>
+    </p:spTree>
+    <p:extLst>
+      <p:ext uri="{BB962C8B-B14F-4D97-AF65-F5344CB8AC3E}">
+        <p14:creationId xmlns:p14="http://schemas.microsoft.com/office/powerpoint/2010/main" val="1765823738"/>
+      </p:ext>
+    </p:extLst>
+  </p:cSld>
+</p:sld>
+</file>
+
+<file path=ppt/slides/slide5.xml><?xml version="1.0" encoding="utf-8"?>
 <p:sld xmlns:p="http://schemas.openxmlformats.org/presentationml/2006/main">
   <p:cSld>
     <p:bg>
@@ -4355,7 +5080,7 @@
                 <a:ea typeface="Alibaba PuHuiTi 3.0"/>
                 <a:cs typeface="Alibaba PuHuiTi 3.0"/>
               </a:rPr>
-              <a:t>03</a:t>
+              <a:t>04</a:t>
             </a:r>
           </a:p>
         </p:txBody>
@@ -4993,7 +5718,7 @@
                 <a:ea typeface="Alibaba PuHuiTi 3.0"/>
                 <a:cs typeface="Alibaba PuHuiTi 3.0"/>
               </a:rPr>
-              <a:t>项目主入口整改事项  04</a:t>
+              <a:t>项目主入口整改事项  05</a:t>
             </a:r>
           </a:p>
         </p:txBody>
@@ -5008,7 +5733,7 @@
 </p:sld>
 </file>
 
-<file path=ppt/slides/slide5.xml><?xml version="1.0" encoding="utf-8"?>
+<file path=ppt/slides/slide6.xml><?xml version="1.0" encoding="utf-8"?>
 <p:sld xmlns:p="http://schemas.openxmlformats.org/presentationml/2006/main">
   <p:cSld>
     <p:bg>
@@ -5080,7 +5805,7 @@
                 <a:ea typeface="Alibaba PuHuiTi 3.0"/>
                 <a:cs typeface="Alibaba PuHuiTi 3.0"/>
               </a:rPr>
-              <a:t>04</a:t>
+              <a:t>05</a:t>
             </a:r>
           </a:p>
         </p:txBody>
@@ -5650,7 +6375,7 @@
                 <a:ea typeface="Alibaba PuHuiTi 3.0"/>
                 <a:cs typeface="Alibaba PuHuiTi 3.0"/>
               </a:rPr>
-              <a:t>项目主入口整改事项  05</a:t>
+              <a:t>项目主入口整改事项  06</a:t>
             </a:r>
           </a:p>
         </p:txBody>
@@ -5665,7 +6390,7 @@
 </p:sld>
 </file>
 
-<file path=ppt/slides/slide6.xml><?xml version="1.0" encoding="utf-8"?>
+<file path=ppt/slides/slide7.xml><?xml version="1.0" encoding="utf-8"?>
 <p:sld xmlns:p="http://schemas.openxmlformats.org/presentationml/2006/main">
   <p:cSld>
     <p:bg>
@@ -5737,7 +6462,7 @@
                 <a:ea typeface="Alibaba PuHuiTi 3.0"/>
                 <a:cs typeface="Alibaba PuHuiTi 3.0"/>
               </a:rPr>
-              <a:t>05</a:t>
+              <a:t>06</a:t>
             </a:r>
           </a:p>
         </p:txBody>
@@ -6051,7 +6776,7 @@
                 <a:ea typeface="Alibaba PuHuiTi 3.0"/>
                 <a:cs typeface="Alibaba PuHuiTi 3.0"/>
               </a:rPr>
-              <a:t>项目主入口整改事项  06</a:t>
+              <a:t>项目主入口整改事项  07</a:t>
             </a:r>
           </a:p>
         </p:txBody>

</xml_diff>